<commit_message>
docs: tighten interview deck narrative
</commit_message>
<xml_diff>
--- a/Executive_Semantic_Layer_Interview_Deck.pptx
+++ b/Executive_Semantic_Layer_Interview_Deck.pptx
@@ -3091,7 +3091,7 @@
 </file>
 
 <file path=ppt/slides/slide1.xml><?xml version="1.0" encoding="utf-8"?>
-<p:sld xmlns:a="http://schemas.openxmlformats.org/drawingml/2006/main" xmlns:p="http://schemas.openxmlformats.org/presentationml/2006/main" xmlns:r="http://schemas.openxmlformats.org/officeDocument/2006/relationships">
+<p:sld xmlns:a="http://schemas.openxmlformats.org/drawingml/2006/main" xmlns:p="http://schemas.openxmlformats.org/presentationml/2006/main">
   <p:cSld>
     <p:spTree>
       <p:nvGrpSpPr>
@@ -3116,7 +3116,7 @@
           <a:lstStyle/>
           <a:p>
             <a:r>
-              <a:t>From Trusted Metrics to AI-Ready Data</a:t>
+              <a:t>One trusted ARR answer, ready for humans and AI</a:t>
             </a:r>
           </a:p>
         </p:txBody>
@@ -3137,12 +3137,12 @@
           <a:lstStyle/>
           <a:p>
             <a:r>
-              <a:t>Introducing a Semantic Layer on Top of the Existing Data Platform</a:t>
-            </a:r>
-          </a:p>
-          <a:p>
-            <a:r>
-              <a:t>One metric end-to-end using ARR as the example</a:t>
+              <a:t>A semantic layer on top of the existing data platform</a:t>
+            </a:r>
+          </a:p>
+          <a:p>
+            <a:r>
+              <a:t>Use ARR as the end-to-end example</a:t>
             </a:r>
           </a:p>
         </p:txBody>
@@ -3156,7 +3156,7 @@
 </file>
 
 <file path=ppt/slides/slide10.xml><?xml version="1.0" encoding="utf-8"?>
-<p:sld xmlns:a="http://schemas.openxmlformats.org/drawingml/2006/main" xmlns:p="http://schemas.openxmlformats.org/presentationml/2006/main" xmlns:r="http://schemas.openxmlformats.org/officeDocument/2006/relationships">
+<p:sld xmlns:a="http://schemas.openxmlformats.org/drawingml/2006/main" xmlns:p="http://schemas.openxmlformats.org/presentationml/2006/main">
   <p:cSld>
     <p:spTree>
       <p:nvGrpSpPr>
@@ -3207,7 +3207,7 @@
           </a:p>
           <a:p>
             <a:r>
-              <a:t>Descriptions, synonyms, approved dimensions, verified queries, access controls.</a:t>
+              <a:t>Approved dimensions, synonyms, lineage, access controls, and verified queries.</a:t>
             </a:r>
           </a:p>
         </p:txBody>
@@ -3221,7 +3221,7 @@
 </file>
 
 <file path=ppt/slides/slide11.xml><?xml version="1.0" encoding="utf-8"?>
-<p:sld xmlns:a="http://schemas.openxmlformats.org/drawingml/2006/main" xmlns:p="http://schemas.openxmlformats.org/presentationml/2006/main" xmlns:r="http://schemas.openxmlformats.org/officeDocument/2006/relationships">
+<p:sld xmlns:a="http://schemas.openxmlformats.org/drawingml/2006/main" xmlns:p="http://schemas.openxmlformats.org/presentationml/2006/main">
   <p:cSld>
     <p:spTree>
       <p:nvGrpSpPr>
@@ -3267,17 +3267,17 @@
           <a:lstStyle/>
           <a:p>
             <a:r>
-              <a:t>Month 1: ARR certification &amp; governance</a:t>
-            </a:r>
-          </a:p>
-          <a:p>
-            <a:r>
-              <a:t>Month 2: GTM metrics</a:t>
-            </a:r>
-          </a:p>
-          <a:p>
-            <a:r>
-              <a:t>Month 3: Product metrics</a:t>
+              <a:t>Month 1: certify ARR and lock ownership</a:t>
+            </a:r>
+          </a:p>
+          <a:p>
+            <a:r>
+              <a:t>Month 2: extend to GTM metrics</a:t>
+            </a:r>
+          </a:p>
+          <a:p>
+            <a:r>
+              <a:t>Month 3: add product metrics and AI-ready access</a:t>
             </a:r>
           </a:p>
         </p:txBody>
@@ -3291,7 +3291,7 @@
 </file>
 
 <file path=ppt/slides/slide12.xml><?xml version="1.0" encoding="utf-8"?>
-<p:sld xmlns:a="http://schemas.openxmlformats.org/drawingml/2006/main" xmlns:p="http://schemas.openxmlformats.org/presentationml/2006/main" xmlns:r="http://schemas.openxmlformats.org/officeDocument/2006/relationships">
+<p:sld xmlns:a="http://schemas.openxmlformats.org/drawingml/2006/main" xmlns:p="http://schemas.openxmlformats.org/presentationml/2006/main">
   <p:cSld>
     <p:spTree>
       <p:nvGrpSpPr>
@@ -3337,7 +3337,7 @@
           <a:lstStyle/>
           <a:p>
             <a:r>
-              <a:t>The same metric, definition and answer across Metabase, Board Reporting, Salesforce and AI Agents.</a:t>
+              <a:t>Metabase, board reporting, Salesforce, and AI should all return the same ARR. If the answer changes by surface, trust has not yet been established.</a:t>
             </a:r>
           </a:p>
         </p:txBody>
@@ -3351,7 +3351,7 @@
 </file>
 
 <file path=ppt/slides/slide13.xml><?xml version="1.0" encoding="utf-8"?>
-<p:sld xmlns:a="http://schemas.openxmlformats.org/drawingml/2006/main" xmlns:p="http://schemas.openxmlformats.org/presentationml/2006/main" xmlns:r="http://schemas.openxmlformats.org/officeDocument/2006/relationships">
+<p:sld xmlns:a="http://schemas.openxmlformats.org/drawingml/2006/main" xmlns:p="http://schemas.openxmlformats.org/presentationml/2006/main">
   <p:cSld>
     <p:spTree>
       <p:nvGrpSpPr>
@@ -3397,12 +3397,12 @@
           <a:lstStyle/>
           <a:p>
             <a:r>
-              <a:t>The goal is not to build a semantic layer.</a:t>
-            </a:r>
-          </a:p>
-          <a:p>
-            <a:r>
-              <a:t>The goal is to create a trusted business vocabulary for humans and AI.</a:t>
+              <a:t>The goal is not another abstraction.</a:t>
+            </a:r>
+          </a:p>
+          <a:p>
+            <a:r>
+              <a:t>The goal is a shared business vocabulary that humans trust and AI can safely use.</a:t>
             </a:r>
           </a:p>
         </p:txBody>
@@ -3416,7 +3416,7 @@
 </file>
 
 <file path=ppt/slides/slide2.xml><?xml version="1.0" encoding="utf-8"?>
-<p:sld xmlns:a="http://schemas.openxmlformats.org/drawingml/2006/main" xmlns:p="http://schemas.openxmlformats.org/presentationml/2006/main" xmlns:r="http://schemas.openxmlformats.org/officeDocument/2006/relationships">
+<p:sld xmlns:a="http://schemas.openxmlformats.org/drawingml/2006/main" xmlns:p="http://schemas.openxmlformats.org/presentationml/2006/main">
   <p:cSld>
     <p:spTree>
       <p:nvGrpSpPr>
@@ -3467,7 +3467,7 @@
           </a:p>
           <a:p>
             <a:r>
-              <a:t>Strong platform foundation already exists.</a:t>
+              <a:t>The platform is strong. The missing piece is a shared meaning layer.</a:t>
             </a:r>
           </a:p>
         </p:txBody>
@@ -3481,7 +3481,7 @@
 </file>
 
 <file path=ppt/slides/slide3.xml><?xml version="1.0" encoding="utf-8"?>
-<p:sld xmlns:a="http://schemas.openxmlformats.org/drawingml/2006/main" xmlns:p="http://schemas.openxmlformats.org/presentationml/2006/main" xmlns:r="http://schemas.openxmlformats.org/officeDocument/2006/relationships">
+<p:sld xmlns:a="http://schemas.openxmlformats.org/drawingml/2006/main" xmlns:p="http://schemas.openxmlformats.org/presentationml/2006/main">
   <p:cSld>
     <p:spTree>
       <p:nvGrpSpPr>
@@ -3527,7 +3527,7 @@
           <a:lstStyle/>
           <a:p>
             <a:r>
-              <a:t>Sources → dbt → Marts → Semantic Layer → Metabase / AI Agents / Reverse ETL</a:t>
+              <a:t>Sources → dbt models → marts → semantic layer → Metabase / AI agents / reverse ETL</a:t>
             </a:r>
           </a:p>
         </p:txBody>
@@ -3541,7 +3541,7 @@
 </file>
 
 <file path=ppt/slides/slide4.xml><?xml version="1.0" encoding="utf-8"?>
-<p:sld xmlns:a="http://schemas.openxmlformats.org/drawingml/2006/main" xmlns:p="http://schemas.openxmlformats.org/presentationml/2006/main" xmlns:r="http://schemas.openxmlformats.org/officeDocument/2006/relationships">
+<p:sld xmlns:a="http://schemas.openxmlformats.org/drawingml/2006/main" xmlns:p="http://schemas.openxmlformats.org/presentationml/2006/main">
   <p:cSld>
     <p:spTree>
       <p:nvGrpSpPr>
@@ -3587,7 +3587,7 @@
           <a:lstStyle/>
           <a:p>
             <a:r>
-              <a:t>Definitions hidden in SQL today. AI agents need governed access to trusted business meaning.</a:t>
+              <a:t>If metric definitions stay trapped in SQL, every dashboard, report, and AI agent can give a different answer. That creates business risk, not just technical debt.</a:t>
             </a:r>
           </a:p>
         </p:txBody>
@@ -3601,7 +3601,7 @@
 </file>
 
 <file path=ppt/slides/slide5.xml><?xml version="1.0" encoding="utf-8"?>
-<p:sld xmlns:a="http://schemas.openxmlformats.org/drawingml/2006/main" xmlns:p="http://schemas.openxmlformats.org/presentationml/2006/main" xmlns:r="http://schemas.openxmlformats.org/officeDocument/2006/relationships">
+<p:sld xmlns:a="http://schemas.openxmlformats.org/drawingml/2006/main" xmlns:p="http://schemas.openxmlformats.org/presentationml/2006/main">
   <p:cSld>
     <p:spTree>
       <p:nvGrpSpPr>
@@ -3647,17 +3647,17 @@
           <a:lstStyle/>
           <a:p>
             <a:r>
-              <a:t>Hybrid approach:</a:t>
-            </a:r>
-          </a:p>
-          <a:p>
-            <a:r>
-              <a:t>• dbt Semantic Models = governance &amp; lineage</a:t>
-            </a:r>
-          </a:p>
-          <a:p>
-            <a:r>
-              <a:t>• Snowflake Semantic Views = AI consumption &amp; discoverability</a:t>
+              <a:t>Keep dbt as the governed source of truth.</a:t>
+            </a:r>
+          </a:p>
+          <a:p>
+            <a:r>
+              <a:t>Publish the certified metric through Snowflake for easy consumption.</a:t>
+            </a:r>
+          </a:p>
+          <a:p>
+            <a:r>
+              <a:t>One definition, two ways to serve it.</a:t>
             </a:r>
           </a:p>
         </p:txBody>
@@ -3671,7 +3671,7 @@
 </file>
 
 <file path=ppt/slides/slide6.xml><?xml version="1.0" encoding="utf-8"?>
-<p:sld xmlns:a="http://schemas.openxmlformats.org/drawingml/2006/main" xmlns:p="http://schemas.openxmlformats.org/presentationml/2006/main" xmlns:r="http://schemas.openxmlformats.org/officeDocument/2006/relationships">
+<p:sld xmlns:a="http://schemas.openxmlformats.org/drawingml/2006/main" xmlns:p="http://schemas.openxmlformats.org/presentationml/2006/main">
   <p:cSld>
     <p:spTree>
       <p:nvGrpSpPr>
@@ -3717,7 +3717,7 @@
           <a:lstStyle/>
           <a:p>
             <a:r>
-              <a:t>Raw → Stage → Intermediate → Mart → Semantic Definition → Metabase → AI Agent</a:t>
+              <a:t>Raw seed → Stage → Intermediate → Mart → Semantic definition → Metabase → AI agent</a:t>
             </a:r>
           </a:p>
         </p:txBody>
@@ -3731,7 +3731,7 @@
 </file>
 
 <file path=ppt/slides/slide7.xml><?xml version="1.0" encoding="utf-8"?>
-<p:sld xmlns:a="http://schemas.openxmlformats.org/drawingml/2006/main" xmlns:p="http://schemas.openxmlformats.org/presentationml/2006/main" xmlns:r="http://schemas.openxmlformats.org/officeDocument/2006/relationships">
+<p:sld xmlns:a="http://schemas.openxmlformats.org/drawingml/2006/main" xmlns:p="http://schemas.openxmlformats.org/presentationml/2006/main">
   <p:cSld>
     <p:spTree>
       <p:nvGrpSpPr>
@@ -3787,7 +3787,7 @@
           </a:p>
           <a:p>
             <a:r>
-              <a:t>Certification is shared.</a:t>
+              <a:t>Certification is shared and documented.</a:t>
             </a:r>
           </a:p>
         </p:txBody>
@@ -3801,7 +3801,7 @@
 </file>
 
 <file path=ppt/slides/slide8.xml><?xml version="1.0" encoding="utf-8"?>
-<p:sld xmlns:a="http://schemas.openxmlformats.org/drawingml/2006/main" xmlns:p="http://schemas.openxmlformats.org/presentationml/2006/main" xmlns:r="http://schemas.openxmlformats.org/officeDocument/2006/relationships">
+<p:sld xmlns:a="http://schemas.openxmlformats.org/drawingml/2006/main" xmlns:p="http://schemas.openxmlformats.org/presentationml/2006/main">
   <p:cSld>
     <p:spTree>
       <p:nvGrpSpPr>
@@ -3847,7 +3847,7 @@
           <a:lstStyle/>
           <a:p>
             <a:r>
-              <a:t>Definition → Data Quality → Reconciliation → Certification → Semantic Publication → AI Consumption</a:t>
+              <a:t>Define the metric → validate the data → reconcile to finance → certify it → publish it. AI reads the certified layer, never a parallel truth.</a:t>
             </a:r>
           </a:p>
         </p:txBody>
@@ -3861,7 +3861,7 @@
 </file>
 
 <file path=ppt/slides/slide9.xml><?xml version="1.0" encoding="utf-8"?>
-<p:sld xmlns:a="http://schemas.openxmlformats.org/drawingml/2006/main" xmlns:p="http://schemas.openxmlformats.org/presentationml/2006/main" xmlns:r="http://schemas.openxmlformats.org/officeDocument/2006/relationships">
+<p:sld xmlns:a="http://schemas.openxmlformats.org/drawingml/2006/main" xmlns:p="http://schemas.openxmlformats.org/presentationml/2006/main">
   <p:cSld>
     <p:spTree>
       <p:nvGrpSpPr>
@@ -3907,12 +3907,12 @@
           <a:lstStyle/>
           <a:p>
             <a:r>
-              <a:t>Salesforce (Booked ARR) + Just-On (Recognized ARR)</a:t>
-            </a:r>
-          </a:p>
-          <a:p>
-            <a:r>
-              <a:t>→ Certified ARR exposed through the semantic layer</a:t>
+              <a:t>Salesforce = booked ARR</a:t>
+            </a:r>
+          </a:p>
+          <a:p>
+            <a:r>
+              <a:t>JustOn = recognized ARR → one certified ARR with traceable exceptions</a:t>
             </a:r>
           </a:p>
         </p:txBody>

</xml_diff>